<commit_message>
run one time again vlm and segmentation.
</commit_message>
<xml_diff>
--- a/Computer_Vision_Presentation.pptx
+++ b/Computer_Vision_Presentation.pptx
@@ -588,7 +588,7 @@
           <a:lstStyle/>
           <a:p>
             <a:r>
-              <a:t>We only run CLIP on car crops above 80×80 px, gating the brand at 0.3 confidence. No hallucinated labels.</a:t>
+              <a:t>This is a real frame from the Stage 2b pipeline. YOLO26s detects the cars (YOLO conf=0.2); CLIP crops each car, runs it through the frozen ViT-B-32 backbone and the learned 512→20 linear probe, and overlays the top-1 brand with confidence. We only run CLIP on car crops above 80×80 px. Trucks are intentionally skipped — the probe was trained on car-only images and would miscalibrate on truck crops. Brand confidence is currently not thresholded (a known limit).</a:t>
             </a:r>
           </a:p>
         </p:txBody>
@@ -728,7 +728,7 @@
           <a:lstStyle/>
           <a:p>
             <a:r>
-              <a:t>Boxes and brands are intermediate outputs. The real product is a sentence: 'A white Toyota is stopping at a red light while pedestrians cross.' That's what a customer demo needs.</a:t>
+              <a:t>This is a real output from Stage 3. YOLO sees 'car, trafficLight' — the VLM narrates 'A red car is driving down a wet road in the rain, approaching a traffic light.' Boxes and brands are intermediate outputs. The real product is a sentence any human can read. That's what a customer demo needs.</a:t>
             </a:r>
           </a:p>
         </p:txBody>
@@ -798,7 +798,7 @@
           <a:lstStyle/>
           <a:p>
             <a:r>
-              <a:t>Qwen3-VL runs locally via Ollama. Captions fire only when the scene actually changes — no redundant narration.</a:t>
+              <a:t>Two real frames from Stage 3, showing adaptive captioning in action. The left frame triggers a 'rainy driving' caption; the right frame triggers a 'pedestrian crossing' caption — because the scene changed enough (diff ≥ 12) and the minimum 5-second interval elapsed. The VLM produces fluent sentences with colour, weather, action, and spatial relationships — not just keyword lists. This is the difference between a detector output and a human-readable story.</a:t>
             </a:r>
           </a:p>
         </p:txBody>
@@ -1008,7 +1008,7 @@
           <a:lstStyle/>
           <a:p>
             <a:r>
-              <a:t>These numbers validate each stage. Detection is production-grade. Brand recognition jumps from 55% zero-shot to 80% with the probe — a 25-point gain from a single linear layer on frozen embeddings. Segmentation leverages a pretrained SOTA model for immediate quality.</a:t>
+              <a:t>Detection: YOLOv10n (P=0.801, R=0.598, mAP@0.5=0.675, mAP@0.5:0.95=0.388) upgraded to YOLO26s (P=0.874, R=0.754, mAP@0.5=0.842, mAP@0.5:0.95=0.515) — a substantial accuracy lift across all metrics. The C2PSA backbone (9.4 M params) generalises well on 11 dashcam classes; pedestrian remains hardest due to scale and occlusion.  Enrichment: Brand recognition jumps from 55% zero-shot to 80% with the probe — a 25-point gain from a single linear layer on frozen embeddings. Segmentation leverages a pretrained SOTA model for immediate quality.</a:t>
             </a:r>
           </a:p>
         </p:txBody>
@@ -1373,7 +1373,7 @@
           <a:lstStyle/>
           <a:p>
             <a:r>
-              <a:t>We upgraded from YOLOv10n to YOLO26s, trading a little speed for greater feature capacity — we'll compare results when training finishes. The dataset covers 11 street classes including nuanced traffic-light states.</a:t>
+              <a:t>YOLOv10n baseline: P=0.801, R=0.598, mAP@0.5=0.675, mAP@0.5:0.95=0.388.  YOLO26s: P=0.874, R=0.754, mAP@0.5=0.842, mAP@0.5:0.95=0.515.  The 9.4 M parameter backbone with C2PSA blocks delivers a significant accuracy lift — especially on recall and strict mAP. Pedestrian remains the hardest class (mAP 0.692) due to scale and occlusion. The dataset covers 11 street classes including nuanced traffic-light states.</a:t>
             </a:r>
           </a:p>
         </p:txBody>
@@ -1443,7 +1443,7 @@
           <a:lstStyle/>
           <a:p>
             <a:r>
-              <a:t>Our newest stage answers the same question as YOLO, but at the pixel level: what is in this scene? Road, sidewalk, building, vegetation — scene geometry, not just boxes.</a:t>
+              <a:t>Our newest stage answers the same question as YOLO, but at the pixel level: what is in this scene? Road (purple), vegetation (green), vehicles (red), sky (blue) — scene geometry, not just boxes. SegFormer-B5 is pretrained on Cityscapes (84% mIoU) and generalises directly to our dashcam domain without any fine-tuning.</a:t>
             </a:r>
           </a:p>
         </p:txBody>
@@ -4992,182 +4992,43 @@
                 </a:solidFill>
                 <a:latin typeface="Calibri"/>
               </a:rPr>
-              <a:t>Car-only crops · confidence ≥ 0.3 · trucks excluded by design</a:t>
-            </a:r>
-          </a:p>
-        </p:txBody>
-      </p:sp>
-      <p:sp>
-        <p:nvSpPr>
-          <p:cNvPr id="6" name="Rounded Rectangle 5"/>
-          <p:cNvSpPr/>
-          <p:nvPr/>
-        </p:nvSpPr>
+              <a:t>Car-only crops · 80×80 min · trucks excluded by design</a:t>
+            </a:r>
+          </a:p>
+        </p:txBody>
+      </p:sp>
+      <p:pic>
+        <p:nvPicPr>
+          <p:cNvPr id="6" name="Picture 5" descr="clip_yolo_result_check.png"/>
+          <p:cNvPicPr>
+            <a:picLocks noChangeAspect="1"/>
+          </p:cNvPicPr>
+          <p:nvPr/>
+        </p:nvPicPr>
+        <p:blipFill>
+          <a:blip r:embed="rId2"/>
+          <a:stretch>
+            <a:fillRect/>
+          </a:stretch>
+        </p:blipFill>
         <p:spPr>
           <a:xfrm>
             <a:off x="822960" y="2011680"/>
-            <a:ext cx="7132320" cy="3657600"/>
-          </a:xfrm>
-          <a:prstGeom prst="roundRect">
-            <a:avLst/>
-          </a:prstGeom>
-          <a:solidFill>
-            <a:srgbClr val="EEF2F6"/>
-          </a:solidFill>
+            <a:ext cx="7132320" cy="4813975"/>
+          </a:xfrm>
+          <a:prstGeom prst="rect">
+            <a:avLst/>
+          </a:prstGeom>
           <a:ln w="12700">
             <a:solidFill>
               <a:srgbClr val="E2E8F0"/>
             </a:solidFill>
           </a:ln>
         </p:spPr>
-        <p:style>
-          <a:lnRef idx="1">
-            <a:schemeClr val="accent1"/>
-          </a:lnRef>
-          <a:fillRef idx="3">
-            <a:schemeClr val="accent1"/>
-          </a:fillRef>
-          <a:effectRef idx="2">
-            <a:schemeClr val="accent1"/>
-          </a:effectRef>
-          <a:fontRef idx="minor">
-            <a:schemeClr val="lt1"/>
-          </a:fontRef>
-        </p:style>
-        <p:txBody>
-          <a:bodyPr rtlCol="0" anchor="ctr"/>
-          <a:lstStyle/>
-          <a:p>
-            <a:pPr algn="ctr"/>
-          </a:p>
-        </p:txBody>
-      </p:sp>
-      <p:sp>
-        <p:nvSpPr>
-          <p:cNvPr id="7" name="Oval 6"/>
-          <p:cNvSpPr/>
-          <p:nvPr/>
-        </p:nvSpPr>
-        <p:spPr>
-          <a:xfrm>
-            <a:off x="3977640" y="3200400"/>
-            <a:ext cx="822960" cy="822960"/>
-          </a:xfrm>
-          <a:prstGeom prst="ellipse">
-            <a:avLst/>
-          </a:prstGeom>
-          <a:solidFill>
-            <a:srgbClr val="FFFFFF"/>
-          </a:solidFill>
-          <a:ln w="19050">
-            <a:solidFill>
-              <a:srgbClr val="E2E8F0"/>
-            </a:solidFill>
-          </a:ln>
-        </p:spPr>
-        <p:style>
-          <a:lnRef idx="1">
-            <a:schemeClr val="accent1"/>
-          </a:lnRef>
-          <a:fillRef idx="3">
-            <a:schemeClr val="accent1"/>
-          </a:fillRef>
-          <a:effectRef idx="2">
-            <a:schemeClr val="accent1"/>
-          </a:effectRef>
-          <a:fontRef idx="minor">
-            <a:schemeClr val="lt1"/>
-          </a:fontRef>
-        </p:style>
-        <p:txBody>
-          <a:bodyPr rtlCol="0" anchor="ctr"/>
-          <a:lstStyle/>
-          <a:p>
-            <a:pPr algn="ctr"/>
-          </a:p>
-        </p:txBody>
-      </p:sp>
-      <p:sp>
-        <p:nvSpPr>
-          <p:cNvPr id="8" name="Isosceles Triangle 7"/>
-          <p:cNvSpPr/>
-          <p:nvPr/>
-        </p:nvSpPr>
-        <p:spPr>
-          <a:xfrm rot="5400000">
-            <a:off x="4270248" y="3447288"/>
-            <a:ext cx="292608" cy="329184"/>
-          </a:xfrm>
-          <a:prstGeom prst="triangle">
-            <a:avLst/>
-          </a:prstGeom>
-          <a:solidFill>
-            <a:srgbClr val="0D9488"/>
-          </a:solidFill>
-          <a:ln>
-            <a:noFill/>
-          </a:ln>
-        </p:spPr>
-        <p:style>
-          <a:lnRef idx="1">
-            <a:schemeClr val="accent1"/>
-          </a:lnRef>
-          <a:fillRef idx="3">
-            <a:schemeClr val="accent1"/>
-          </a:fillRef>
-          <a:effectRef idx="2">
-            <a:schemeClr val="accent1"/>
-          </a:effectRef>
-          <a:fontRef idx="minor">
-            <a:schemeClr val="lt1"/>
-          </a:fontRef>
-        </p:style>
-        <p:txBody>
-          <a:bodyPr rtlCol="0" anchor="ctr"/>
-          <a:lstStyle/>
-          <a:p>
-            <a:pPr algn="ctr"/>
-          </a:p>
-        </p:txBody>
-      </p:sp>
-      <p:sp>
-        <p:nvSpPr>
-          <p:cNvPr id="9" name="TextBox 8"/>
-          <p:cNvSpPr txBox="1"/>
-          <p:nvPr/>
-        </p:nvSpPr>
-        <p:spPr>
-          <a:xfrm>
-            <a:off x="822960" y="4114800"/>
-            <a:ext cx="7132320" cy="731520"/>
-          </a:xfrm>
-          <a:prstGeom prst="rect">
-            <a:avLst/>
-          </a:prstGeom>
-          <a:noFill/>
-        </p:spPr>
-        <p:txBody>
-          <a:bodyPr wrap="square">
-            <a:spAutoFit/>
-          </a:bodyPr>
-          <a:lstStyle/>
-          <a:p>
-            <a:pPr algn="ctr"/>
-            <a:r>
-              <a:rPr sz="1300" b="0">
-                <a:solidFill>
-                  <a:srgbClr val="475569"/>
-                </a:solidFill>
-                <a:latin typeface="Calibri"/>
-              </a:rPr>
-              <a:t>Full annotated video (YOLO + CLIP) — 5-sec clip showing brand chip</a:t>
-            </a:r>
-          </a:p>
-        </p:txBody>
-      </p:sp>
-      <p:sp>
-        <p:nvSpPr>
-          <p:cNvPr id="10" name="Rounded Rectangle 9"/>
+      </p:pic>
+      <p:sp>
+        <p:nvSpPr>
+          <p:cNvPr id="7" name="Rounded Rectangle 6"/>
           <p:cNvSpPr/>
           <p:nvPr/>
         </p:nvSpPr>
@@ -5212,7 +5073,7 @@
       </p:sp>
       <p:sp>
         <p:nvSpPr>
-          <p:cNvPr id="11" name="TextBox 10"/>
+          <p:cNvPr id="8" name="TextBox 7"/>
           <p:cNvSpPr txBox="1"/>
           <p:nvPr/>
         </p:nvSpPr>
@@ -5247,7 +5108,7 @@
       </p:sp>
       <p:sp>
         <p:nvSpPr>
-          <p:cNvPr id="12" name="Rounded Rectangle 11"/>
+          <p:cNvPr id="9" name="Rounded Rectangle 8"/>
           <p:cNvSpPr/>
           <p:nvPr/>
         </p:nvSpPr>
@@ -5292,7 +5153,7 @@
       </p:sp>
       <p:sp>
         <p:nvSpPr>
-          <p:cNvPr id="13" name="TextBox 12"/>
+          <p:cNvPr id="10" name="TextBox 9"/>
           <p:cNvSpPr txBox="1"/>
           <p:nvPr/>
         </p:nvSpPr>
@@ -5327,7 +5188,7 @@
       </p:sp>
       <p:sp>
         <p:nvSpPr>
-          <p:cNvPr id="14" name="Rounded Rectangle 13"/>
+          <p:cNvPr id="11" name="Rounded Rectangle 10"/>
           <p:cNvSpPr/>
           <p:nvPr/>
         </p:nvSpPr>
@@ -5372,7 +5233,7 @@
       </p:sp>
       <p:sp>
         <p:nvSpPr>
-          <p:cNvPr id="15" name="TextBox 14"/>
+          <p:cNvPr id="12" name="TextBox 11"/>
           <p:cNvSpPr txBox="1"/>
           <p:nvPr/>
         </p:nvSpPr>
@@ -5407,7 +5268,7 @@
       </p:sp>
       <p:sp>
         <p:nvSpPr>
-          <p:cNvPr id="16" name="Rounded Rectangle 15"/>
+          <p:cNvPr id="13" name="Rounded Rectangle 12"/>
           <p:cNvSpPr/>
           <p:nvPr/>
         </p:nvSpPr>
@@ -5452,7 +5313,7 @@
       </p:sp>
       <p:sp>
         <p:nvSpPr>
-          <p:cNvPr id="17" name="TextBox 16"/>
+          <p:cNvPr id="14" name="TextBox 13"/>
           <p:cNvSpPr txBox="1"/>
           <p:nvPr/>
         </p:nvSpPr>
@@ -5487,7 +5348,7 @@
       </p:sp>
       <p:sp>
         <p:nvSpPr>
-          <p:cNvPr id="18" name="Rounded Rectangle 17"/>
+          <p:cNvPr id="15" name="Rounded Rectangle 14"/>
           <p:cNvSpPr/>
           <p:nvPr/>
         </p:nvSpPr>
@@ -5532,7 +5393,7 @@
       </p:sp>
       <p:sp>
         <p:nvSpPr>
-          <p:cNvPr id="19" name="TextBox 18"/>
+          <p:cNvPr id="16" name="TextBox 15"/>
           <p:cNvSpPr txBox="1"/>
           <p:nvPr/>
         </p:nvSpPr>
@@ -5567,7 +5428,7 @@
       </p:sp>
       <p:sp>
         <p:nvSpPr>
-          <p:cNvPr id="20" name="TextBox 19"/>
+          <p:cNvPr id="17" name="TextBox 16"/>
           <p:cNvSpPr txBox="1"/>
           <p:nvPr/>
         </p:nvSpPr>
@@ -5595,7 +5456,7 @@
                 </a:solidFill>
                 <a:latin typeface="Calibri"/>
               </a:rPr>
-              <a:t>Trucks are out-of-distribution for the probe; drawing a brand on them would be misleading.</a:t>
+              <a:t>Real output: YOLO26s boxes + CLIP brand chips (BMW, Peugeot …). Trucks excluded by design — car-only probe.</a:t>
             </a:r>
           </a:p>
         </p:txBody>
@@ -5999,149 +5860,45 @@
           </a:p>
         </p:txBody>
       </p:sp>
-      <p:sp>
-        <p:nvSpPr>
-          <p:cNvPr id="5" name="Rounded Rectangle 4"/>
-          <p:cNvSpPr/>
-          <p:nvPr/>
-        </p:nvSpPr>
-        <p:spPr>
-          <a:xfrm>
-            <a:off x="1463040" y="1828800"/>
-            <a:ext cx="9235440" cy="3657600"/>
-          </a:xfrm>
-          <a:prstGeom prst="roundRect">
-            <a:avLst/>
-          </a:prstGeom>
-          <a:solidFill>
-            <a:srgbClr val="EEF2F6"/>
-          </a:solidFill>
+      <p:pic>
+        <p:nvPicPr>
+          <p:cNvPr id="5" name="Picture 4" descr="vlm_caption_red_car_rain.png"/>
+          <p:cNvPicPr>
+            <a:picLocks noChangeAspect="1"/>
+          </p:cNvPicPr>
+          <p:nvPr/>
+        </p:nvPicPr>
+        <p:blipFill>
+          <a:blip r:embed="rId2"/>
+          <a:stretch>
+            <a:fillRect/>
+          </a:stretch>
+        </p:blipFill>
+        <p:spPr>
+          <a:xfrm>
+            <a:off x="1828800" y="1828800"/>
+            <a:ext cx="8503920" cy="2113644"/>
+          </a:xfrm>
+          <a:prstGeom prst="rect">
+            <a:avLst/>
+          </a:prstGeom>
           <a:ln w="12700">
             <a:solidFill>
               <a:srgbClr val="E2E8F0"/>
             </a:solidFill>
           </a:ln>
         </p:spPr>
-        <p:style>
-          <a:lnRef idx="1">
-            <a:schemeClr val="accent1"/>
-          </a:lnRef>
-          <a:fillRef idx="3">
-            <a:schemeClr val="accent1"/>
-          </a:fillRef>
-          <a:effectRef idx="2">
-            <a:schemeClr val="accent1"/>
-          </a:effectRef>
-          <a:fontRef idx="minor">
-            <a:schemeClr val="lt1"/>
-          </a:fontRef>
-        </p:style>
-        <p:txBody>
-          <a:bodyPr rtlCol="0" anchor="ctr"/>
-          <a:lstStyle/>
-          <a:p>
-            <a:pPr algn="ctr"/>
-          </a:p>
-        </p:txBody>
-      </p:sp>
-      <p:sp>
-        <p:nvSpPr>
-          <p:cNvPr id="6" name="Oval 5"/>
-          <p:cNvSpPr/>
-          <p:nvPr/>
-        </p:nvSpPr>
-        <p:spPr>
-          <a:xfrm>
-            <a:off x="5669280" y="3017520"/>
-            <a:ext cx="822960" cy="822960"/>
-          </a:xfrm>
-          <a:prstGeom prst="ellipse">
-            <a:avLst/>
-          </a:prstGeom>
-          <a:solidFill>
-            <a:srgbClr val="FFFFFF"/>
-          </a:solidFill>
-          <a:ln w="19050">
-            <a:solidFill>
-              <a:srgbClr val="E2E8F0"/>
-            </a:solidFill>
-          </a:ln>
-        </p:spPr>
-        <p:style>
-          <a:lnRef idx="1">
-            <a:schemeClr val="accent1"/>
-          </a:lnRef>
-          <a:fillRef idx="3">
-            <a:schemeClr val="accent1"/>
-          </a:fillRef>
-          <a:effectRef idx="2">
-            <a:schemeClr val="accent1"/>
-          </a:effectRef>
-          <a:fontRef idx="minor">
-            <a:schemeClr val="lt1"/>
-          </a:fontRef>
-        </p:style>
-        <p:txBody>
-          <a:bodyPr rtlCol="0" anchor="ctr"/>
-          <a:lstStyle/>
-          <a:p>
-            <a:pPr algn="ctr"/>
-          </a:p>
-        </p:txBody>
-      </p:sp>
-      <p:sp>
-        <p:nvSpPr>
-          <p:cNvPr id="7" name="Isosceles Triangle 6"/>
-          <p:cNvSpPr/>
-          <p:nvPr/>
-        </p:nvSpPr>
-        <p:spPr>
-          <a:xfrm rot="5400000">
-            <a:off x="5961888" y="3264408"/>
-            <a:ext cx="292608" cy="329184"/>
-          </a:xfrm>
-          <a:prstGeom prst="triangle">
-            <a:avLst/>
-          </a:prstGeom>
-          <a:solidFill>
-            <a:srgbClr val="0D9488"/>
-          </a:solidFill>
-          <a:ln>
-            <a:noFill/>
-          </a:ln>
-        </p:spPr>
-        <p:style>
-          <a:lnRef idx="1">
-            <a:schemeClr val="accent1"/>
-          </a:lnRef>
-          <a:fillRef idx="3">
-            <a:schemeClr val="accent1"/>
-          </a:fillRef>
-          <a:effectRef idx="2">
-            <a:schemeClr val="accent1"/>
-          </a:effectRef>
-          <a:fontRef idx="minor">
-            <a:schemeClr val="lt1"/>
-          </a:fontRef>
-        </p:style>
-        <p:txBody>
-          <a:bodyPr rtlCol="0" anchor="ctr"/>
-          <a:lstStyle/>
-          <a:p>
-            <a:pPr algn="ctr"/>
-          </a:p>
-        </p:txBody>
-      </p:sp>
-      <p:sp>
-        <p:nvSpPr>
-          <p:cNvPr id="8" name="TextBox 7"/>
+      </p:pic>
+      <p:sp>
+        <p:nvSpPr>
+          <p:cNvPr id="6" name="TextBox 5"/>
           <p:cNvSpPr txBox="1"/>
           <p:nvPr/>
         </p:nvSpPr>
         <p:spPr>
           <a:xfrm>
-            <a:off x="1463040" y="3931920"/>
-            <a:ext cx="9235440" cy="731520"/>
+            <a:off x="1828800" y="5623560"/>
+            <a:ext cx="8503920" cy="457200"/>
           </a:xfrm>
           <a:prstGeom prst="rect">
             <a:avLst/>
@@ -6156,20 +5913,20 @@
           <a:p>
             <a:pPr algn="ctr"/>
             <a:r>
-              <a:rPr sz="1300" b="0">
+              <a:rPr sz="1400" b="0">
                 <a:solidFill>
-                  <a:srgbClr val="475569"/>
+                  <a:srgbClr val="6366F1"/>
                 </a:solidFill>
                 <a:latin typeface="Calibri"/>
               </a:rPr>
-              <a:t>VLM captioned video — caption banner appearing dynamically (5-sec clip)</a:t>
-            </a:r>
-          </a:p>
-        </p:txBody>
-      </p:sp>
-      <p:sp>
-        <p:nvSpPr>
-          <p:cNvPr id="9" name="TextBox 8"/>
+              <a:t>"A red car is driving down a wet road in the rain, approaching a traffic light."</a:t>
+            </a:r>
+          </a:p>
+        </p:txBody>
+      </p:sp>
+      <p:sp>
+        <p:nvSpPr>
+          <p:cNvPr id="7" name="TextBox 6"/>
           <p:cNvSpPr txBox="1"/>
           <p:nvPr/>
         </p:nvSpPr>
@@ -6384,149 +6141,45 @@
           </a:p>
         </p:txBody>
       </p:sp>
-      <p:sp>
-        <p:nvSpPr>
-          <p:cNvPr id="6" name="Rounded Rectangle 5"/>
-          <p:cNvSpPr/>
-          <p:nvPr/>
-        </p:nvSpPr>
+      <p:pic>
+        <p:nvPicPr>
+          <p:cNvPr id="6" name="Picture 5" descr="vlm_caption_red_car_rain.png"/>
+          <p:cNvPicPr>
+            <a:picLocks noChangeAspect="1"/>
+          </p:cNvPicPr>
+          <p:nvPr/>
+        </p:nvPicPr>
+        <p:blipFill>
+          <a:blip r:embed="rId2"/>
+          <a:stretch>
+            <a:fillRect/>
+          </a:stretch>
+        </p:blipFill>
         <p:spPr>
           <a:xfrm>
             <a:off x="822960" y="2011680"/>
-            <a:ext cx="5120640" cy="3657600"/>
-          </a:xfrm>
-          <a:prstGeom prst="roundRect">
-            <a:avLst/>
-          </a:prstGeom>
-          <a:solidFill>
-            <a:srgbClr val="EEF2F6"/>
-          </a:solidFill>
+            <a:ext cx="5120640" cy="1272732"/>
+          </a:xfrm>
+          <a:prstGeom prst="rect">
+            <a:avLst/>
+          </a:prstGeom>
           <a:ln w="12700">
             <a:solidFill>
               <a:srgbClr val="E2E8F0"/>
             </a:solidFill>
           </a:ln>
         </p:spPr>
-        <p:style>
-          <a:lnRef idx="1">
-            <a:schemeClr val="accent1"/>
-          </a:lnRef>
-          <a:fillRef idx="3">
-            <a:schemeClr val="accent1"/>
-          </a:fillRef>
-          <a:effectRef idx="2">
-            <a:schemeClr val="accent1"/>
-          </a:effectRef>
-          <a:fontRef idx="minor">
-            <a:schemeClr val="lt1"/>
-          </a:fontRef>
-        </p:style>
-        <p:txBody>
-          <a:bodyPr rtlCol="0" anchor="ctr"/>
-          <a:lstStyle/>
-          <a:p>
-            <a:pPr algn="ctr"/>
-          </a:p>
-        </p:txBody>
-      </p:sp>
-      <p:sp>
-        <p:nvSpPr>
-          <p:cNvPr id="7" name="Oval 6"/>
-          <p:cNvSpPr/>
-          <p:nvPr/>
-        </p:nvSpPr>
-        <p:spPr>
-          <a:xfrm>
-            <a:off x="2971800" y="3200400"/>
-            <a:ext cx="822960" cy="822960"/>
-          </a:xfrm>
-          <a:prstGeom prst="ellipse">
-            <a:avLst/>
-          </a:prstGeom>
-          <a:solidFill>
-            <a:srgbClr val="FFFFFF"/>
-          </a:solidFill>
-          <a:ln w="19050">
-            <a:solidFill>
-              <a:srgbClr val="E2E8F0"/>
-            </a:solidFill>
-          </a:ln>
-        </p:spPr>
-        <p:style>
-          <a:lnRef idx="1">
-            <a:schemeClr val="accent1"/>
-          </a:lnRef>
-          <a:fillRef idx="3">
-            <a:schemeClr val="accent1"/>
-          </a:fillRef>
-          <a:effectRef idx="2">
-            <a:schemeClr val="accent1"/>
-          </a:effectRef>
-          <a:fontRef idx="minor">
-            <a:schemeClr val="lt1"/>
-          </a:fontRef>
-        </p:style>
-        <p:txBody>
-          <a:bodyPr rtlCol="0" anchor="ctr"/>
-          <a:lstStyle/>
-          <a:p>
-            <a:pPr algn="ctr"/>
-          </a:p>
-        </p:txBody>
-      </p:sp>
-      <p:sp>
-        <p:nvSpPr>
-          <p:cNvPr id="8" name="Isosceles Triangle 7"/>
-          <p:cNvSpPr/>
-          <p:nvPr/>
-        </p:nvSpPr>
-        <p:spPr>
-          <a:xfrm rot="5400000">
-            <a:off x="3264408" y="3447288"/>
-            <a:ext cx="292608" cy="329184"/>
-          </a:xfrm>
-          <a:prstGeom prst="triangle">
-            <a:avLst/>
-          </a:prstGeom>
-          <a:solidFill>
-            <a:srgbClr val="0D9488"/>
-          </a:solidFill>
-          <a:ln>
-            <a:noFill/>
-          </a:ln>
-        </p:spPr>
-        <p:style>
-          <a:lnRef idx="1">
-            <a:schemeClr val="accent1"/>
-          </a:lnRef>
-          <a:fillRef idx="3">
-            <a:schemeClr val="accent1"/>
-          </a:fillRef>
-          <a:effectRef idx="2">
-            <a:schemeClr val="accent1"/>
-          </a:effectRef>
-          <a:fontRef idx="minor">
-            <a:schemeClr val="lt1"/>
-          </a:fontRef>
-        </p:style>
-        <p:txBody>
-          <a:bodyPr rtlCol="0" anchor="ctr"/>
-          <a:lstStyle/>
-          <a:p>
-            <a:pPr algn="ctr"/>
-          </a:p>
-        </p:txBody>
-      </p:sp>
-      <p:sp>
-        <p:nvSpPr>
-          <p:cNvPr id="9" name="TextBox 8"/>
+      </p:pic>
+      <p:sp>
+        <p:nvSpPr>
+          <p:cNvPr id="7" name="TextBox 6"/>
           <p:cNvSpPr txBox="1"/>
           <p:nvPr/>
         </p:nvSpPr>
         <p:spPr>
           <a:xfrm>
-            <a:off x="822960" y="4114800"/>
-            <a:ext cx="5120640" cy="731520"/>
+            <a:off x="822960" y="5623560"/>
+            <a:ext cx="5120640" cy="457200"/>
           </a:xfrm>
           <a:prstGeom prst="rect">
             <a:avLst/>
@@ -6541,160 +6194,56 @@
           <a:p>
             <a:pPr algn="ctr"/>
             <a:r>
-              <a:rPr sz="1300" b="0">
+              <a:rPr sz="1200" b="0">
                 <a:solidFill>
-                  <a:srgbClr val="475569"/>
+                  <a:srgbClr val="6366F1"/>
                 </a:solidFill>
                 <a:latin typeface="Calibri"/>
               </a:rPr>
-              <a:t>Static caption</a:t>
-            </a:r>
-          </a:p>
-        </p:txBody>
-      </p:sp>
-      <p:sp>
-        <p:nvSpPr>
-          <p:cNvPr id="10" name="Rounded Rectangle 9"/>
-          <p:cNvSpPr/>
-          <p:nvPr/>
-        </p:nvSpPr>
+              <a:t>"A red car is driving down a wet road in the rain, approaching a traffic light."</a:t>
+            </a:r>
+          </a:p>
+        </p:txBody>
+      </p:sp>
+      <p:pic>
+        <p:nvPicPr>
+          <p:cNvPr id="8" name="Picture 7" descr="vlm_caption_truck_pedestrian.png"/>
+          <p:cNvPicPr>
+            <a:picLocks noChangeAspect="1"/>
+          </p:cNvPicPr>
+          <p:nvPr/>
+        </p:nvPicPr>
+        <p:blipFill>
+          <a:blip r:embed="rId3"/>
+          <a:stretch>
+            <a:fillRect/>
+          </a:stretch>
+        </p:blipFill>
         <p:spPr>
           <a:xfrm>
             <a:off x="6245352" y="2011680"/>
-            <a:ext cx="5120640" cy="3657600"/>
-          </a:xfrm>
-          <a:prstGeom prst="roundRect">
-            <a:avLst/>
-          </a:prstGeom>
-          <a:solidFill>
-            <a:srgbClr val="EEF2F6"/>
-          </a:solidFill>
+            <a:ext cx="5120640" cy="1381681"/>
+          </a:xfrm>
+          <a:prstGeom prst="rect">
+            <a:avLst/>
+          </a:prstGeom>
           <a:ln w="12700">
             <a:solidFill>
               <a:srgbClr val="E2E8F0"/>
             </a:solidFill>
           </a:ln>
         </p:spPr>
-        <p:style>
-          <a:lnRef idx="1">
-            <a:schemeClr val="accent1"/>
-          </a:lnRef>
-          <a:fillRef idx="3">
-            <a:schemeClr val="accent1"/>
-          </a:fillRef>
-          <a:effectRef idx="2">
-            <a:schemeClr val="accent1"/>
-          </a:effectRef>
-          <a:fontRef idx="minor">
-            <a:schemeClr val="lt1"/>
-          </a:fontRef>
-        </p:style>
-        <p:txBody>
-          <a:bodyPr rtlCol="0" anchor="ctr"/>
-          <a:lstStyle/>
-          <a:p>
-            <a:pPr algn="ctr"/>
-          </a:p>
-        </p:txBody>
-      </p:sp>
-      <p:sp>
-        <p:nvSpPr>
-          <p:cNvPr id="11" name="Oval 10"/>
-          <p:cNvSpPr/>
-          <p:nvPr/>
-        </p:nvSpPr>
-        <p:spPr>
-          <a:xfrm>
-            <a:off x="8394192" y="3200400"/>
-            <a:ext cx="822960" cy="822960"/>
-          </a:xfrm>
-          <a:prstGeom prst="ellipse">
-            <a:avLst/>
-          </a:prstGeom>
-          <a:solidFill>
-            <a:srgbClr val="FFFFFF"/>
-          </a:solidFill>
-          <a:ln w="19050">
-            <a:solidFill>
-              <a:srgbClr val="E2E8F0"/>
-            </a:solidFill>
-          </a:ln>
-        </p:spPr>
-        <p:style>
-          <a:lnRef idx="1">
-            <a:schemeClr val="accent1"/>
-          </a:lnRef>
-          <a:fillRef idx="3">
-            <a:schemeClr val="accent1"/>
-          </a:fillRef>
-          <a:effectRef idx="2">
-            <a:schemeClr val="accent1"/>
-          </a:effectRef>
-          <a:fontRef idx="minor">
-            <a:schemeClr val="lt1"/>
-          </a:fontRef>
-        </p:style>
-        <p:txBody>
-          <a:bodyPr rtlCol="0" anchor="ctr"/>
-          <a:lstStyle/>
-          <a:p>
-            <a:pPr algn="ctr"/>
-          </a:p>
-        </p:txBody>
-      </p:sp>
-      <p:sp>
-        <p:nvSpPr>
-          <p:cNvPr id="12" name="Isosceles Triangle 11"/>
-          <p:cNvSpPr/>
-          <p:nvPr/>
-        </p:nvSpPr>
-        <p:spPr>
-          <a:xfrm rot="5400000">
-            <a:off x="8686800" y="3447288"/>
-            <a:ext cx="292608" cy="329184"/>
-          </a:xfrm>
-          <a:prstGeom prst="triangle">
-            <a:avLst/>
-          </a:prstGeom>
-          <a:solidFill>
-            <a:srgbClr val="0D9488"/>
-          </a:solidFill>
-          <a:ln>
-            <a:noFill/>
-          </a:ln>
-        </p:spPr>
-        <p:style>
-          <a:lnRef idx="1">
-            <a:schemeClr val="accent1"/>
-          </a:lnRef>
-          <a:fillRef idx="3">
-            <a:schemeClr val="accent1"/>
-          </a:fillRef>
-          <a:effectRef idx="2">
-            <a:schemeClr val="accent1"/>
-          </a:effectRef>
-          <a:fontRef idx="minor">
-            <a:schemeClr val="lt1"/>
-          </a:fontRef>
-        </p:style>
-        <p:txBody>
-          <a:bodyPr rtlCol="0" anchor="ctr"/>
-          <a:lstStyle/>
-          <a:p>
-            <a:pPr algn="ctr"/>
-          </a:p>
-        </p:txBody>
-      </p:sp>
-      <p:sp>
-        <p:nvSpPr>
-          <p:cNvPr id="13" name="TextBox 12"/>
+      </p:pic>
+      <p:sp>
+        <p:nvSpPr>
+          <p:cNvPr id="9" name="TextBox 8"/>
           <p:cNvSpPr txBox="1"/>
           <p:nvPr/>
         </p:nvSpPr>
         <p:spPr>
           <a:xfrm>
-            <a:off x="6245352" y="4114800"/>
-            <a:ext cx="5120640" cy="731520"/>
+            <a:off x="6245352" y="5623560"/>
+            <a:ext cx="5120640" cy="457200"/>
           </a:xfrm>
           <a:prstGeom prst="rect">
             <a:avLst/>
@@ -6709,20 +6258,20 @@
           <a:p>
             <a:pPr algn="ctr"/>
             <a:r>
-              <a:rPr sz="1300" b="0">
+              <a:rPr sz="1200" b="0">
                 <a:solidFill>
-                  <a:srgbClr val="475569"/>
+                  <a:srgbClr val="6366F1"/>
                 </a:solidFill>
                 <a:latin typeface="Calibri"/>
               </a:rPr>
-              <a:t>Adaptive caption (scene change)</a:t>
-            </a:r>
-          </a:p>
-        </p:txBody>
-      </p:sp>
-      <p:sp>
-        <p:nvSpPr>
-          <p:cNvPr id="14" name="TextBox 13"/>
+              <a:t>"A white truck and a pedestrian are crossing the road at a pedestrian crossing..."</a:t>
+            </a:r>
+          </a:p>
+        </p:txBody>
+      </p:sp>
+      <p:sp>
+        <p:nvSpPr>
+          <p:cNvPr id="10" name="TextBox 9"/>
           <p:cNvSpPr txBox="1"/>
           <p:nvPr/>
         </p:nvSpPr>
@@ -8608,7 +8157,7 @@
                 </a:solidFill>
                 <a:latin typeface="Calibri"/>
               </a:rPr>
-              <a:t>mAP@0.5 ≈ _._</a:t>
+              <a:t>P = 0.874</a:t>
             </a:r>
           </a:p>
           <a:p>
@@ -8620,7 +8169,31 @@
                 </a:solidFill>
                 <a:latin typeface="Calibri"/>
               </a:rPr>
-              <a:t>mAP@0.5:0.95 ≈ _._</a:t>
+              <a:t>R = 0.754</a:t>
+            </a:r>
+          </a:p>
+          <a:p>
+            <a:pPr algn="ctr"/>
+            <a:r>
+              <a:rPr sz="1300" b="0">
+                <a:solidFill>
+                  <a:srgbClr val="475569"/>
+                </a:solidFill>
+                <a:latin typeface="Calibri"/>
+              </a:rPr>
+              <a:t>mAP@0.5 = 0.842</a:t>
+            </a:r>
+          </a:p>
+          <a:p>
+            <a:pPr algn="ctr"/>
+            <a:r>
+              <a:rPr sz="1300" b="0">
+                <a:solidFill>
+                  <a:srgbClr val="475569"/>
+                </a:solidFill>
+                <a:latin typeface="Calibri"/>
+              </a:rPr>
+              <a:t>mAP@0.5:0.95 = 0.515</a:t>
             </a:r>
           </a:p>
         </p:txBody>
@@ -8778,7 +8351,7 @@
                 </a:solidFill>
                 <a:latin typeface="Calibri"/>
               </a:rPr>
-              <a:t>Probe accuracy ≈ _._ %</a:t>
+              <a:t>Probe accuracy ≈ 80 %</a:t>
             </a:r>
           </a:p>
           <a:p>
@@ -8791,6 +8364,18 @@
                 <a:latin typeface="Calibri"/>
               </a:rPr>
               <a:t>20 brands</a:t>
+            </a:r>
+          </a:p>
+          <a:p>
+            <a:pPr algn="ctr"/>
+            <a:r>
+              <a:rPr sz="1300" b="0">
+                <a:solidFill>
+                  <a:srgbClr val="475569"/>
+                </a:solidFill>
+                <a:latin typeface="Calibri"/>
+              </a:rPr>
+              <a:t>(79.8 % on test split)</a:t>
             </a:r>
           </a:p>
         </p:txBody>
@@ -9143,7 +8728,7 @@
         </p:nvSpPr>
         <p:spPr>
           <a:xfrm>
-            <a:off x="822960" y="4572000"/>
+            <a:off x="822960" y="5029200"/>
             <a:ext cx="10545775" cy="457200"/>
           </a:xfrm>
           <a:prstGeom prst="rect">
@@ -9165,42 +8750,7 @@
                 </a:solidFill>
                 <a:latin typeface="Calibri"/>
               </a:rPr>
-              <a:t>Note: 0.68 was the old YOLOv10n baseline; insert new YOLO26s values.</a:t>
-            </a:r>
-          </a:p>
-        </p:txBody>
-      </p:sp>
-      <p:sp>
-        <p:nvSpPr>
-          <p:cNvPr id="21" name="TextBox 20"/>
-          <p:cNvSpPr txBox="1"/>
-          <p:nvPr/>
-        </p:nvSpPr>
-        <p:spPr>
-          <a:xfrm>
-            <a:off x="822960" y="4983480"/>
-            <a:ext cx="10545775" cy="457200"/>
-          </a:xfrm>
-          <a:prstGeom prst="rect">
-            <a:avLst/>
-          </a:prstGeom>
-          <a:noFill/>
-        </p:spPr>
-        <p:txBody>
-          <a:bodyPr wrap="square">
-            <a:spAutoFit/>
-          </a:bodyPr>
-          <a:lstStyle/>
-          <a:p>
-            <a:pPr algn="l"/>
-            <a:r>
-              <a:rPr sz="1300" b="0">
-                <a:solidFill>
-                  <a:srgbClr val="94A3B8"/>
-                </a:solidFill>
-                <a:latin typeface="Calibri"/>
-              </a:rPr>
-              <a:t>Leave blank spaces for the actual results.png and confusion-matrix screenshots.</a:t>
+              <a:t>YOLOv10n baseline → YOLO26s:  +24.7% mAP@0.5,  +32.7% mAP@0.5:0.95,  +26.1% recall.  Hardest class: pedestrian (mAP 0.692).</a:t>
             </a:r>
           </a:p>
         </p:txBody>
@@ -10450,7 +10000,7 @@
         </p:nvSpPr>
         <p:spPr>
           <a:xfrm>
-            <a:off x="868680" y="1691640"/>
+            <a:off x="822960" y="1691640"/>
             <a:ext cx="4663440" cy="3931920"/>
           </a:xfrm>
           <a:prstGeom prst="roundRect">
@@ -10495,7 +10045,7 @@
         </p:nvSpPr>
         <p:spPr>
           <a:xfrm>
-            <a:off x="2788920" y="3017520"/>
+            <a:off x="2743200" y="3017520"/>
             <a:ext cx="822960" cy="822960"/>
           </a:xfrm>
           <a:prstGeom prst="ellipse">
@@ -10540,7 +10090,7 @@
         </p:nvSpPr>
         <p:spPr>
           <a:xfrm rot="5400000">
-            <a:off x="3081528" y="3264408"/>
+            <a:off x="3035808" y="3264408"/>
             <a:ext cx="292608" cy="329184"/>
           </a:xfrm>
           <a:prstGeom prst="triangle">
@@ -10583,7 +10133,7 @@
         </p:nvSpPr>
         <p:spPr>
           <a:xfrm>
-            <a:off x="868680" y="3931920"/>
+            <a:off x="822960" y="3931920"/>
             <a:ext cx="4663440" cy="731520"/>
           </a:xfrm>
           <a:prstGeom prst="rect">
@@ -10998,7 +10548,7 @@
                 </a:solidFill>
                 <a:latin typeface="Calibri"/>
               </a:rPr>
-              <a:t>11 classes · 512 px · 30 epochs · mAP@0.5 ≈ _._ (fill after rerun)</a:t>
+              <a:t>11 classes · 512 px · 30 epochs · mAP@0.5 = 0.842  ·  mAP@0.5:0.95 = 0.515</a:t>
             </a:r>
           </a:p>
         </p:txBody>
@@ -11675,7 +11225,7 @@
                 </a:solidFill>
                 <a:latin typeface="Calibri"/>
               </a:rPr>
-              <a:t>Backbone upgraded from YOLOv10n to YOLO26s for better feature capacity; trained on Self-Driving-Car-3.</a:t>
+              <a:t>Upgraded from YOLOv10n → YOLO26s:  +24.7% mAP@0.5,  +32.7% mAP@0.5:0.95,  +26.1% recall  (11-class Self-Driving-Car-3, 30 epochs).</a:t>
             </a:r>
           </a:p>
         </p:txBody>
@@ -11862,149 +11412,45 @@
           </a:p>
         </p:txBody>
       </p:sp>
-      <p:sp>
-        <p:nvSpPr>
-          <p:cNvPr id="6" name="Rounded Rectangle 5"/>
-          <p:cNvSpPr/>
-          <p:nvPr/>
-        </p:nvSpPr>
+      <p:pic>
+        <p:nvPicPr>
+          <p:cNvPr id="6" name="Picture 5" descr="segformer_original.png"/>
+          <p:cNvPicPr>
+            <a:picLocks noChangeAspect="1"/>
+          </p:cNvPicPr>
+          <p:nvPr/>
+        </p:nvPicPr>
+        <p:blipFill>
+          <a:blip r:embed="rId2"/>
+          <a:stretch>
+            <a:fillRect/>
+          </a:stretch>
+        </p:blipFill>
         <p:spPr>
           <a:xfrm>
             <a:off x="822960" y="2011680"/>
-            <a:ext cx="3383280" cy="3657600"/>
-          </a:xfrm>
-          <a:prstGeom prst="roundRect">
-            <a:avLst/>
-          </a:prstGeom>
-          <a:solidFill>
-            <a:srgbClr val="EEF2F6"/>
-          </a:solidFill>
+            <a:ext cx="3383280" cy="2413164"/>
+          </a:xfrm>
+          <a:prstGeom prst="rect">
+            <a:avLst/>
+          </a:prstGeom>
           <a:ln w="12700">
             <a:solidFill>
               <a:srgbClr val="E2E8F0"/>
             </a:solidFill>
           </a:ln>
         </p:spPr>
-        <p:style>
-          <a:lnRef idx="1">
-            <a:schemeClr val="accent1"/>
-          </a:lnRef>
-          <a:fillRef idx="3">
-            <a:schemeClr val="accent1"/>
-          </a:fillRef>
-          <a:effectRef idx="2">
-            <a:schemeClr val="accent1"/>
-          </a:effectRef>
-          <a:fontRef idx="minor">
-            <a:schemeClr val="lt1"/>
-          </a:fontRef>
-        </p:style>
-        <p:txBody>
-          <a:bodyPr rtlCol="0" anchor="ctr"/>
-          <a:lstStyle/>
-          <a:p>
-            <a:pPr algn="ctr"/>
-          </a:p>
-        </p:txBody>
-      </p:sp>
-      <p:sp>
-        <p:nvSpPr>
-          <p:cNvPr id="7" name="Oval 6"/>
-          <p:cNvSpPr/>
-          <p:nvPr/>
-        </p:nvSpPr>
-        <p:spPr>
-          <a:xfrm>
-            <a:off x="2103120" y="3200400"/>
-            <a:ext cx="822960" cy="822960"/>
-          </a:xfrm>
-          <a:prstGeom prst="ellipse">
-            <a:avLst/>
-          </a:prstGeom>
-          <a:solidFill>
-            <a:srgbClr val="FFFFFF"/>
-          </a:solidFill>
-          <a:ln w="19050">
-            <a:solidFill>
-              <a:srgbClr val="E2E8F0"/>
-            </a:solidFill>
-          </a:ln>
-        </p:spPr>
-        <p:style>
-          <a:lnRef idx="1">
-            <a:schemeClr val="accent1"/>
-          </a:lnRef>
-          <a:fillRef idx="3">
-            <a:schemeClr val="accent1"/>
-          </a:fillRef>
-          <a:effectRef idx="2">
-            <a:schemeClr val="accent1"/>
-          </a:effectRef>
-          <a:fontRef idx="minor">
-            <a:schemeClr val="lt1"/>
-          </a:fontRef>
-        </p:style>
-        <p:txBody>
-          <a:bodyPr rtlCol="0" anchor="ctr"/>
-          <a:lstStyle/>
-          <a:p>
-            <a:pPr algn="ctr"/>
-          </a:p>
-        </p:txBody>
-      </p:sp>
-      <p:sp>
-        <p:nvSpPr>
-          <p:cNvPr id="8" name="Isosceles Triangle 7"/>
-          <p:cNvSpPr/>
-          <p:nvPr/>
-        </p:nvSpPr>
-        <p:spPr>
-          <a:xfrm rot="5400000">
-            <a:off x="2395728" y="3447288"/>
-            <a:ext cx="292608" cy="329184"/>
-          </a:xfrm>
-          <a:prstGeom prst="triangle">
-            <a:avLst/>
-          </a:prstGeom>
-          <a:solidFill>
-            <a:srgbClr val="0D9488"/>
-          </a:solidFill>
-          <a:ln>
-            <a:noFill/>
-          </a:ln>
-        </p:spPr>
-        <p:style>
-          <a:lnRef idx="1">
-            <a:schemeClr val="accent1"/>
-          </a:lnRef>
-          <a:fillRef idx="3">
-            <a:schemeClr val="accent1"/>
-          </a:fillRef>
-          <a:effectRef idx="2">
-            <a:schemeClr val="accent1"/>
-          </a:effectRef>
-          <a:fontRef idx="minor">
-            <a:schemeClr val="lt1"/>
-          </a:fontRef>
-        </p:style>
-        <p:txBody>
-          <a:bodyPr rtlCol="0" anchor="ctr"/>
-          <a:lstStyle/>
-          <a:p>
-            <a:pPr algn="ctr"/>
-          </a:p>
-        </p:txBody>
-      </p:sp>
-      <p:sp>
-        <p:nvSpPr>
-          <p:cNvPr id="9" name="TextBox 8"/>
+      </p:pic>
+      <p:sp>
+        <p:nvSpPr>
+          <p:cNvPr id="7" name="TextBox 6"/>
           <p:cNvSpPr txBox="1"/>
           <p:nvPr/>
         </p:nvSpPr>
         <p:spPr>
           <a:xfrm>
-            <a:off x="822960" y="4114800"/>
-            <a:ext cx="3383280" cy="731520"/>
+            <a:off x="822960" y="5623560"/>
+            <a:ext cx="3383280" cy="457200"/>
           </a:xfrm>
           <a:prstGeom prst="rect">
             <a:avLst/>
@@ -12019,9 +11465,9 @@
           <a:p>
             <a:pPr algn="ctr"/>
             <a:r>
-              <a:rPr sz="1300" b="0">
+              <a:rPr sz="1200" b="1">
                 <a:solidFill>
-                  <a:srgbClr val="475569"/>
+                  <a:srgbClr val="0D9488"/>
                 </a:solidFill>
                 <a:latin typeface="Calibri"/>
               </a:rPr>
@@ -12030,149 +11476,45 @@
           </a:p>
         </p:txBody>
       </p:sp>
-      <p:sp>
-        <p:nvSpPr>
-          <p:cNvPr id="10" name="Rounded Rectangle 9"/>
-          <p:cNvSpPr/>
-          <p:nvPr/>
-        </p:nvSpPr>
+      <p:pic>
+        <p:nvPicPr>
+          <p:cNvPr id="8" name="Picture 7" descr="segformer_mask.png"/>
+          <p:cNvPicPr>
+            <a:picLocks noChangeAspect="1"/>
+          </p:cNvPicPr>
+          <p:nvPr/>
+        </p:nvPicPr>
+        <p:blipFill>
+          <a:blip r:embed="rId3"/>
+          <a:stretch>
+            <a:fillRect/>
+          </a:stretch>
+        </p:blipFill>
         <p:spPr>
           <a:xfrm>
             <a:off x="4407408" y="2011680"/>
-            <a:ext cx="3383280" cy="3657600"/>
-          </a:xfrm>
-          <a:prstGeom prst="roundRect">
-            <a:avLst/>
-          </a:prstGeom>
-          <a:solidFill>
-            <a:srgbClr val="EEF2F6"/>
-          </a:solidFill>
+            <a:ext cx="3383280" cy="2158508"/>
+          </a:xfrm>
+          <a:prstGeom prst="rect">
+            <a:avLst/>
+          </a:prstGeom>
           <a:ln w="12700">
             <a:solidFill>
               <a:srgbClr val="E2E8F0"/>
             </a:solidFill>
           </a:ln>
         </p:spPr>
-        <p:style>
-          <a:lnRef idx="1">
-            <a:schemeClr val="accent1"/>
-          </a:lnRef>
-          <a:fillRef idx="3">
-            <a:schemeClr val="accent1"/>
-          </a:fillRef>
-          <a:effectRef idx="2">
-            <a:schemeClr val="accent1"/>
-          </a:effectRef>
-          <a:fontRef idx="minor">
-            <a:schemeClr val="lt1"/>
-          </a:fontRef>
-        </p:style>
-        <p:txBody>
-          <a:bodyPr rtlCol="0" anchor="ctr"/>
-          <a:lstStyle/>
-          <a:p>
-            <a:pPr algn="ctr"/>
-          </a:p>
-        </p:txBody>
-      </p:sp>
-      <p:sp>
-        <p:nvSpPr>
-          <p:cNvPr id="11" name="Oval 10"/>
-          <p:cNvSpPr/>
-          <p:nvPr/>
-        </p:nvSpPr>
-        <p:spPr>
-          <a:xfrm>
-            <a:off x="5687568" y="3200400"/>
-            <a:ext cx="822960" cy="822960"/>
-          </a:xfrm>
-          <a:prstGeom prst="ellipse">
-            <a:avLst/>
-          </a:prstGeom>
-          <a:solidFill>
-            <a:srgbClr val="FFFFFF"/>
-          </a:solidFill>
-          <a:ln w="19050">
-            <a:solidFill>
-              <a:srgbClr val="E2E8F0"/>
-            </a:solidFill>
-          </a:ln>
-        </p:spPr>
-        <p:style>
-          <a:lnRef idx="1">
-            <a:schemeClr val="accent1"/>
-          </a:lnRef>
-          <a:fillRef idx="3">
-            <a:schemeClr val="accent1"/>
-          </a:fillRef>
-          <a:effectRef idx="2">
-            <a:schemeClr val="accent1"/>
-          </a:effectRef>
-          <a:fontRef idx="minor">
-            <a:schemeClr val="lt1"/>
-          </a:fontRef>
-        </p:style>
-        <p:txBody>
-          <a:bodyPr rtlCol="0" anchor="ctr"/>
-          <a:lstStyle/>
-          <a:p>
-            <a:pPr algn="ctr"/>
-          </a:p>
-        </p:txBody>
-      </p:sp>
-      <p:sp>
-        <p:nvSpPr>
-          <p:cNvPr id="12" name="Isosceles Triangle 11"/>
-          <p:cNvSpPr/>
-          <p:nvPr/>
-        </p:nvSpPr>
-        <p:spPr>
-          <a:xfrm rot="5400000">
-            <a:off x="5980176" y="3447288"/>
-            <a:ext cx="292608" cy="329184"/>
-          </a:xfrm>
-          <a:prstGeom prst="triangle">
-            <a:avLst/>
-          </a:prstGeom>
-          <a:solidFill>
-            <a:srgbClr val="0D9488"/>
-          </a:solidFill>
-          <a:ln>
-            <a:noFill/>
-          </a:ln>
-        </p:spPr>
-        <p:style>
-          <a:lnRef idx="1">
-            <a:schemeClr val="accent1"/>
-          </a:lnRef>
-          <a:fillRef idx="3">
-            <a:schemeClr val="accent1"/>
-          </a:fillRef>
-          <a:effectRef idx="2">
-            <a:schemeClr val="accent1"/>
-          </a:effectRef>
-          <a:fontRef idx="minor">
-            <a:schemeClr val="lt1"/>
-          </a:fontRef>
-        </p:style>
-        <p:txBody>
-          <a:bodyPr rtlCol="0" anchor="ctr"/>
-          <a:lstStyle/>
-          <a:p>
-            <a:pPr algn="ctr"/>
-          </a:p>
-        </p:txBody>
-      </p:sp>
-      <p:sp>
-        <p:nvSpPr>
-          <p:cNvPr id="13" name="TextBox 12"/>
+      </p:pic>
+      <p:sp>
+        <p:nvSpPr>
+          <p:cNvPr id="9" name="TextBox 8"/>
           <p:cNvSpPr txBox="1"/>
           <p:nvPr/>
         </p:nvSpPr>
         <p:spPr>
           <a:xfrm>
-            <a:off x="4407408" y="4114800"/>
-            <a:ext cx="3383280" cy="731520"/>
+            <a:off x="4407408" y="5623560"/>
+            <a:ext cx="3383280" cy="457200"/>
           </a:xfrm>
           <a:prstGeom prst="rect">
             <a:avLst/>
@@ -12187,160 +11529,56 @@
           <a:p>
             <a:pPr algn="ctr"/>
             <a:r>
-              <a:rPr sz="1300" b="0">
+              <a:rPr sz="1200" b="1">
                 <a:solidFill>
-                  <a:srgbClr val="475569"/>
+                  <a:srgbClr val="0D9488"/>
                 </a:solidFill>
                 <a:latin typeface="Calibri"/>
               </a:rPr>
-              <a:t>Segmentation Mask</a:t>
-            </a:r>
-          </a:p>
-        </p:txBody>
-      </p:sp>
-      <p:sp>
-        <p:nvSpPr>
-          <p:cNvPr id="14" name="Rounded Rectangle 13"/>
-          <p:cNvSpPr/>
-          <p:nvPr/>
-        </p:nvSpPr>
+              <a:t>Mask</a:t>
+            </a:r>
+          </a:p>
+        </p:txBody>
+      </p:sp>
+      <p:pic>
+        <p:nvPicPr>
+          <p:cNvPr id="10" name="Picture 9" descr="segformer_blended.png"/>
+          <p:cNvPicPr>
+            <a:picLocks noChangeAspect="1"/>
+          </p:cNvPicPr>
+          <p:nvPr/>
+        </p:nvPicPr>
+        <p:blipFill>
+          <a:blip r:embed="rId4"/>
+          <a:stretch>
+            <a:fillRect/>
+          </a:stretch>
+        </p:blipFill>
         <p:spPr>
           <a:xfrm>
             <a:off x="7991856" y="2011680"/>
-            <a:ext cx="3383280" cy="3657600"/>
-          </a:xfrm>
-          <a:prstGeom prst="roundRect">
-            <a:avLst/>
-          </a:prstGeom>
-          <a:solidFill>
-            <a:srgbClr val="EEF2F6"/>
-          </a:solidFill>
+            <a:ext cx="3383280" cy="2263298"/>
+          </a:xfrm>
+          <a:prstGeom prst="rect">
+            <a:avLst/>
+          </a:prstGeom>
           <a:ln w="12700">
             <a:solidFill>
               <a:srgbClr val="E2E8F0"/>
             </a:solidFill>
           </a:ln>
         </p:spPr>
-        <p:style>
-          <a:lnRef idx="1">
-            <a:schemeClr val="accent1"/>
-          </a:lnRef>
-          <a:fillRef idx="3">
-            <a:schemeClr val="accent1"/>
-          </a:fillRef>
-          <a:effectRef idx="2">
-            <a:schemeClr val="accent1"/>
-          </a:effectRef>
-          <a:fontRef idx="minor">
-            <a:schemeClr val="lt1"/>
-          </a:fontRef>
-        </p:style>
-        <p:txBody>
-          <a:bodyPr rtlCol="0" anchor="ctr"/>
-          <a:lstStyle/>
-          <a:p>
-            <a:pPr algn="ctr"/>
-          </a:p>
-        </p:txBody>
-      </p:sp>
-      <p:sp>
-        <p:nvSpPr>
-          <p:cNvPr id="15" name="Oval 14"/>
-          <p:cNvSpPr/>
-          <p:nvPr/>
-        </p:nvSpPr>
-        <p:spPr>
-          <a:xfrm>
-            <a:off x="9272016" y="3200400"/>
-            <a:ext cx="822960" cy="822960"/>
-          </a:xfrm>
-          <a:prstGeom prst="ellipse">
-            <a:avLst/>
-          </a:prstGeom>
-          <a:solidFill>
-            <a:srgbClr val="FFFFFF"/>
-          </a:solidFill>
-          <a:ln w="19050">
-            <a:solidFill>
-              <a:srgbClr val="E2E8F0"/>
-            </a:solidFill>
-          </a:ln>
-        </p:spPr>
-        <p:style>
-          <a:lnRef idx="1">
-            <a:schemeClr val="accent1"/>
-          </a:lnRef>
-          <a:fillRef idx="3">
-            <a:schemeClr val="accent1"/>
-          </a:fillRef>
-          <a:effectRef idx="2">
-            <a:schemeClr val="accent1"/>
-          </a:effectRef>
-          <a:fontRef idx="minor">
-            <a:schemeClr val="lt1"/>
-          </a:fontRef>
-        </p:style>
-        <p:txBody>
-          <a:bodyPr rtlCol="0" anchor="ctr"/>
-          <a:lstStyle/>
-          <a:p>
-            <a:pPr algn="ctr"/>
-          </a:p>
-        </p:txBody>
-      </p:sp>
-      <p:sp>
-        <p:nvSpPr>
-          <p:cNvPr id="16" name="Isosceles Triangle 15"/>
-          <p:cNvSpPr/>
-          <p:nvPr/>
-        </p:nvSpPr>
-        <p:spPr>
-          <a:xfrm rot="5400000">
-            <a:off x="9564624" y="3447288"/>
-            <a:ext cx="292608" cy="329184"/>
-          </a:xfrm>
-          <a:prstGeom prst="triangle">
-            <a:avLst/>
-          </a:prstGeom>
-          <a:solidFill>
-            <a:srgbClr val="0D9488"/>
-          </a:solidFill>
-          <a:ln>
-            <a:noFill/>
-          </a:ln>
-        </p:spPr>
-        <p:style>
-          <a:lnRef idx="1">
-            <a:schemeClr val="accent1"/>
-          </a:lnRef>
-          <a:fillRef idx="3">
-            <a:schemeClr val="accent1"/>
-          </a:fillRef>
-          <a:effectRef idx="2">
-            <a:schemeClr val="accent1"/>
-          </a:effectRef>
-          <a:fontRef idx="minor">
-            <a:schemeClr val="lt1"/>
-          </a:fontRef>
-        </p:style>
-        <p:txBody>
-          <a:bodyPr rtlCol="0" anchor="ctr"/>
-          <a:lstStyle/>
-          <a:p>
-            <a:pPr algn="ctr"/>
-          </a:p>
-        </p:txBody>
-      </p:sp>
-      <p:sp>
-        <p:nvSpPr>
-          <p:cNvPr id="17" name="TextBox 16"/>
+      </p:pic>
+      <p:sp>
+        <p:nvSpPr>
+          <p:cNvPr id="11" name="TextBox 10"/>
           <p:cNvSpPr txBox="1"/>
           <p:nvPr/>
         </p:nvSpPr>
         <p:spPr>
           <a:xfrm>
-            <a:off x="7991856" y="4114800"/>
-            <a:ext cx="3383280" cy="731520"/>
+            <a:off x="7991856" y="5623560"/>
+            <a:ext cx="3383280" cy="457200"/>
           </a:xfrm>
           <a:prstGeom prst="rect">
             <a:avLst/>
@@ -12355,20 +11593,20 @@
           <a:p>
             <a:pPr algn="ctr"/>
             <a:r>
-              <a:rPr sz="1300" b="0">
+              <a:rPr sz="1200" b="1">
                 <a:solidFill>
-                  <a:srgbClr val="475569"/>
+                  <a:srgbClr val="0D9488"/>
                 </a:solidFill>
                 <a:latin typeface="Calibri"/>
               </a:rPr>
-              <a:t>Overlay</a:t>
-            </a:r>
-          </a:p>
-        </p:txBody>
-      </p:sp>
-      <p:sp>
-        <p:nvSpPr>
-          <p:cNvPr id="18" name="TextBox 17"/>
+              <a:t>Overlay (α=0.5)</a:t>
+            </a:r>
+          </a:p>
+        </p:txBody>
+      </p:sp>
+      <p:sp>
+        <p:nvSpPr>
+          <p:cNvPr id="12" name="TextBox 11"/>
           <p:cNvSpPr txBox="1"/>
           <p:nvPr/>
         </p:nvSpPr>
@@ -12396,7 +11634,7 @@
                 </a:solidFill>
                 <a:latin typeface="Calibri"/>
               </a:rPr>
-              <a:t>Nearest-neighbor upsampling preserves boundaries; not real-time by design — a quality demonstration.</a:t>
+              <a:t>Nearest-neighbor upsampling preserves boundaries; 2,516 frames at ~5 it/s (~8 min) — quality demo, not real-time.</a:t>
             </a:r>
           </a:p>
         </p:txBody>

</xml_diff>